<commit_message>
docs: sync Overleaf manuscript and figure revisions
Integrate author text and figure edits, preserve generation sources, add the supplemental note build, and refresh manuscript review PDFs.
</commit_message>
<xml_diff>
--- a/figures/results_pbi2/pbi2.pptx
+++ b/figures/results_pbi2/pbi2.pptx
@@ -4064,7 +4064,7 @@
                   <a:schemeClr val="bg1"/>
                 </a:solidFill>
               </a:rPr>
-              <a:t>m=1</a:t>
+              <a:t>r=1</a:t>
             </a:r>
           </a:p>
         </p:txBody>
@@ -4103,7 +4103,7 @@
                   <a:schemeClr val="bg1"/>
                 </a:solidFill>
               </a:rPr>
-              <a:t>m=0</a:t>
+              <a:t>r=0</a:t>
             </a:r>
           </a:p>
         </p:txBody>

</xml_diff>